<commit_message>
Updates reading lists, addresses additional bugs and typos.
</commit_message>
<xml_diff>
--- a/slides/cata_intro.pptx
+++ b/slides/cata_intro.pptx
@@ -174,201 +174,6 @@
 
 <file path=ppt/changesInfos/changesInfo1.xml><?xml version="1.0" encoding="utf-8"?>
 <pc:chgInfo xmlns:a="http://schemas.openxmlformats.org/drawingml/2006/main" xmlns:r="http://schemas.openxmlformats.org/officeDocument/2006/relationships" xmlns:ac="http://schemas.microsoft.com/office/drawing/2013/main/command" xmlns:pc="http://schemas.microsoft.com/office/powerpoint/2013/main/command">
-  <pc:docChgLst>
-    <pc:chgData name="Aaron McKenny" userId="8c9d190a88911c18" providerId="LiveId" clId="{8DE0DA05-B572-4B66-A6A4-358C9A0232A5}"/>
-    <pc:docChg chg="undo custSel addSld delSld modSld sldOrd">
-      <pc:chgData name="Aaron McKenny" userId="8c9d190a88911c18" providerId="LiveId" clId="{8DE0DA05-B572-4B66-A6A4-358C9A0232A5}" dt="2025-01-21T19:29:34.997" v="2219" actId="20577"/>
-      <pc:docMkLst>
-        <pc:docMk/>
-      </pc:docMkLst>
-      <pc:sldChg chg="modSp mod">
-        <pc:chgData name="Aaron McKenny" userId="8c9d190a88911c18" providerId="LiveId" clId="{8DE0DA05-B572-4B66-A6A4-358C9A0232A5}" dt="2025-01-21T19:25:28.049" v="2034" actId="948"/>
-        <pc:sldMkLst>
-          <pc:docMk/>
-          <pc:sldMk cId="1323249328" sldId="277"/>
-        </pc:sldMkLst>
-        <pc:spChg chg="mod">
-          <ac:chgData name="Aaron McKenny" userId="8c9d190a88911c18" providerId="LiveId" clId="{8DE0DA05-B572-4B66-A6A4-358C9A0232A5}" dt="2025-01-21T19:24:50.968" v="1966" actId="20577"/>
-          <ac:spMkLst>
-            <pc:docMk/>
-            <pc:sldMk cId="1323249328" sldId="277"/>
-            <ac:spMk id="2" creationId="{21DC9B4B-025C-B2D9-D736-11C2B87A803A}"/>
-          </ac:spMkLst>
-        </pc:spChg>
-        <pc:spChg chg="mod">
-          <ac:chgData name="Aaron McKenny" userId="8c9d190a88911c18" providerId="LiveId" clId="{8DE0DA05-B572-4B66-A6A4-358C9A0232A5}" dt="2025-01-21T19:25:28.049" v="2034" actId="948"/>
-          <ac:spMkLst>
-            <pc:docMk/>
-            <pc:sldMk cId="1323249328" sldId="277"/>
-            <ac:spMk id="3" creationId="{68C8CB05-75F8-5AB9-B604-7FEA7BBEF4D9}"/>
-          </ac:spMkLst>
-        </pc:spChg>
-      </pc:sldChg>
-      <pc:sldChg chg="modSp mod">
-        <pc:chgData name="Aaron McKenny" userId="8c9d190a88911c18" providerId="LiveId" clId="{8DE0DA05-B572-4B66-A6A4-358C9A0232A5}" dt="2025-01-21T18:43:11.626" v="728" actId="20577"/>
-        <pc:sldMkLst>
-          <pc:docMk/>
-          <pc:sldMk cId="3096737779" sldId="279"/>
-        </pc:sldMkLst>
-        <pc:spChg chg="mod">
-          <ac:chgData name="Aaron McKenny" userId="8c9d190a88911c18" providerId="LiveId" clId="{8DE0DA05-B572-4B66-A6A4-358C9A0232A5}" dt="2025-01-21T18:43:11.626" v="728" actId="20577"/>
-          <ac:spMkLst>
-            <pc:docMk/>
-            <pc:sldMk cId="3096737779" sldId="279"/>
-            <ac:spMk id="3" creationId="{FBE600EF-8BC0-0721-2362-EC492736C742}"/>
-          </ac:spMkLst>
-        </pc:spChg>
-      </pc:sldChg>
-      <pc:sldChg chg="modSp mod">
-        <pc:chgData name="Aaron McKenny" userId="8c9d190a88911c18" providerId="LiveId" clId="{8DE0DA05-B572-4B66-A6A4-358C9A0232A5}" dt="2025-01-21T19:02:34.740" v="1372" actId="20577"/>
-        <pc:sldMkLst>
-          <pc:docMk/>
-          <pc:sldMk cId="1849440115" sldId="280"/>
-        </pc:sldMkLst>
-        <pc:spChg chg="mod">
-          <ac:chgData name="Aaron McKenny" userId="8c9d190a88911c18" providerId="LiveId" clId="{8DE0DA05-B572-4B66-A6A4-358C9A0232A5}" dt="2025-01-21T19:02:34.740" v="1372" actId="20577"/>
-          <ac:spMkLst>
-            <pc:docMk/>
-            <pc:sldMk cId="1849440115" sldId="280"/>
-            <ac:spMk id="3" creationId="{775378BB-6208-6FD2-F870-6A2489052CA6}"/>
-          </ac:spMkLst>
-        </pc:spChg>
-      </pc:sldChg>
-      <pc:sldChg chg="modSp mod">
-        <pc:chgData name="Aaron McKenny" userId="8c9d190a88911c18" providerId="LiveId" clId="{8DE0DA05-B572-4B66-A6A4-358C9A0232A5}" dt="2025-01-21T19:12:03.950" v="1619" actId="20577"/>
-        <pc:sldMkLst>
-          <pc:docMk/>
-          <pc:sldMk cId="3188424627" sldId="281"/>
-        </pc:sldMkLst>
-      </pc:sldChg>
-      <pc:sldChg chg="modSp mod">
-        <pc:chgData name="Aaron McKenny" userId="8c9d190a88911c18" providerId="LiveId" clId="{8DE0DA05-B572-4B66-A6A4-358C9A0232A5}" dt="2025-01-21T18:25:36.731" v="197" actId="20577"/>
-        <pc:sldMkLst>
-          <pc:docMk/>
-          <pc:sldMk cId="1287068090" sldId="288"/>
-        </pc:sldMkLst>
-      </pc:sldChg>
-      <pc:sldChg chg="modSp mod">
-        <pc:chgData name="Aaron McKenny" userId="8c9d190a88911c18" providerId="LiveId" clId="{8DE0DA05-B572-4B66-A6A4-358C9A0232A5}" dt="2025-01-21T19:29:34.997" v="2219" actId="20577"/>
-        <pc:sldMkLst>
-          <pc:docMk/>
-          <pc:sldMk cId="441169049" sldId="298"/>
-        </pc:sldMkLst>
-        <pc:spChg chg="mod">
-          <ac:chgData name="Aaron McKenny" userId="8c9d190a88911c18" providerId="LiveId" clId="{8DE0DA05-B572-4B66-A6A4-358C9A0232A5}" dt="2025-01-21T19:26:10.103" v="2071" actId="20577"/>
-          <ac:spMkLst>
-            <pc:docMk/>
-            <pc:sldMk cId="441169049" sldId="298"/>
-            <ac:spMk id="2" creationId="{9402D7F2-35BB-D947-F043-0B88E04899E0}"/>
-          </ac:spMkLst>
-        </pc:spChg>
-        <pc:spChg chg="mod">
-          <ac:chgData name="Aaron McKenny" userId="8c9d190a88911c18" providerId="LiveId" clId="{8DE0DA05-B572-4B66-A6A4-358C9A0232A5}" dt="2025-01-21T19:29:34.997" v="2219" actId="20577"/>
-          <ac:spMkLst>
-            <pc:docMk/>
-            <pc:sldMk cId="441169049" sldId="298"/>
-            <ac:spMk id="3" creationId="{1BB4A81E-9C5A-B504-8D81-CB4C8EA621BF}"/>
-          </ac:spMkLst>
-        </pc:spChg>
-      </pc:sldChg>
-      <pc:sldChg chg="modSp mod">
-        <pc:chgData name="Aaron McKenny" userId="8c9d190a88911c18" providerId="LiveId" clId="{8DE0DA05-B572-4B66-A6A4-358C9A0232A5}" dt="2025-01-21T18:24:48.304" v="193" actId="20577"/>
-        <pc:sldMkLst>
-          <pc:docMk/>
-          <pc:sldMk cId="347184342" sldId="300"/>
-        </pc:sldMkLst>
-        <pc:spChg chg="mod">
-          <ac:chgData name="Aaron McKenny" userId="8c9d190a88911c18" providerId="LiveId" clId="{8DE0DA05-B572-4B66-A6A4-358C9A0232A5}" dt="2025-01-21T18:24:48.304" v="193" actId="20577"/>
-          <ac:spMkLst>
-            <pc:docMk/>
-            <pc:sldMk cId="347184342" sldId="300"/>
-            <ac:spMk id="3" creationId="{0F1E47E1-FCED-AEBE-977C-5A0B03585940}"/>
-          </ac:spMkLst>
-        </pc:spChg>
-        <pc:picChg chg="mod">
-          <ac:chgData name="Aaron McKenny" userId="8c9d190a88911c18" providerId="LiveId" clId="{8DE0DA05-B572-4B66-A6A4-358C9A0232A5}" dt="2025-01-21T18:24:29.532" v="182" actId="14100"/>
-          <ac:picMkLst>
-            <pc:docMk/>
-            <pc:sldMk cId="347184342" sldId="300"/>
-            <ac:picMk id="5" creationId="{FEA625B2-5095-C498-1BF1-9511546A2084}"/>
-          </ac:picMkLst>
-        </pc:picChg>
-      </pc:sldChg>
-      <pc:sldChg chg="ord">
-        <pc:chgData name="Aaron McKenny" userId="8c9d190a88911c18" providerId="LiveId" clId="{8DE0DA05-B572-4B66-A6A4-358C9A0232A5}" dt="2025-01-21T16:54:36.042" v="42"/>
-        <pc:sldMkLst>
-          <pc:docMk/>
-          <pc:sldMk cId="3113912552" sldId="351"/>
-        </pc:sldMkLst>
-      </pc:sldChg>
-      <pc:sldChg chg="modSp del mod">
-        <pc:chgData name="Aaron McKenny" userId="8c9d190a88911c18" providerId="LiveId" clId="{8DE0DA05-B572-4B66-A6A4-358C9A0232A5}" dt="2025-01-21T18:24:55.681" v="194" actId="47"/>
-        <pc:sldMkLst>
-          <pc:docMk/>
-          <pc:sldMk cId="3956547567" sldId="356"/>
-        </pc:sldMkLst>
-      </pc:sldChg>
-      <pc:sldChg chg="modSp mod">
-        <pc:chgData name="Aaron McKenny" userId="8c9d190a88911c18" providerId="LiveId" clId="{8DE0DA05-B572-4B66-A6A4-358C9A0232A5}" dt="2025-01-21T18:49:21.839" v="1099" actId="20577"/>
-        <pc:sldMkLst>
-          <pc:docMk/>
-          <pc:sldMk cId="4212261276" sldId="357"/>
-        </pc:sldMkLst>
-        <pc:spChg chg="mod">
-          <ac:chgData name="Aaron McKenny" userId="8c9d190a88911c18" providerId="LiveId" clId="{8DE0DA05-B572-4B66-A6A4-358C9A0232A5}" dt="2025-01-21T18:49:21.839" v="1099" actId="20577"/>
-          <ac:spMkLst>
-            <pc:docMk/>
-            <pc:sldMk cId="4212261276" sldId="357"/>
-            <ac:spMk id="3" creationId="{32EEEBCE-0ADB-8187-2DCD-4E0168AA282D}"/>
-          </ac:spMkLst>
-        </pc:spChg>
-      </pc:sldChg>
-      <pc:sldChg chg="modSp mod">
-        <pc:chgData name="Aaron McKenny" userId="8c9d190a88911c18" providerId="LiveId" clId="{8DE0DA05-B572-4B66-A6A4-358C9A0232A5}" dt="2025-01-21T19:23:49.165" v="1943" actId="20577"/>
-        <pc:sldMkLst>
-          <pc:docMk/>
-          <pc:sldMk cId="3661507078" sldId="358"/>
-        </pc:sldMkLst>
-      </pc:sldChg>
-      <pc:sldChg chg="modSp new del mod">
-        <pc:chgData name="Aaron McKenny" userId="8c9d190a88911c18" providerId="LiveId" clId="{8DE0DA05-B572-4B66-A6A4-358C9A0232A5}" dt="2025-01-21T16:51:32.898" v="7" actId="47"/>
-        <pc:sldMkLst>
-          <pc:docMk/>
-          <pc:sldMk cId="3281436423" sldId="360"/>
-        </pc:sldMkLst>
-      </pc:sldChg>
-      <pc:sldChg chg="addSp modSp add mod">
-        <pc:chgData name="Aaron McKenny" userId="8c9d190a88911c18" providerId="LiveId" clId="{8DE0DA05-B572-4B66-A6A4-358C9A0232A5}" dt="2025-01-21T18:26:08.444" v="201" actId="5793"/>
-        <pc:sldMkLst>
-          <pc:docMk/>
-          <pc:sldMk cId="686485639" sldId="361"/>
-        </pc:sldMkLst>
-      </pc:sldChg>
-      <pc:sldChg chg="modSp new mod">
-        <pc:chgData name="Aaron McKenny" userId="8c9d190a88911c18" providerId="LiveId" clId="{8DE0DA05-B572-4B66-A6A4-358C9A0232A5}" dt="2025-01-21T18:23:27.646" v="138" actId="21"/>
-        <pc:sldMkLst>
-          <pc:docMk/>
-          <pc:sldMk cId="81377919" sldId="362"/>
-        </pc:sldMkLst>
-        <pc:spChg chg="mod">
-          <ac:chgData name="Aaron McKenny" userId="8c9d190a88911c18" providerId="LiveId" clId="{8DE0DA05-B572-4B66-A6A4-358C9A0232A5}" dt="2025-01-21T16:57:37.448" v="68" actId="20577"/>
-          <ac:spMkLst>
-            <pc:docMk/>
-            <pc:sldMk cId="81377919" sldId="362"/>
-            <ac:spMk id="2" creationId="{EDF66317-9779-FA0A-8853-6A2401F4F16E}"/>
-          </ac:spMkLst>
-        </pc:spChg>
-        <pc:spChg chg="mod">
-          <ac:chgData name="Aaron McKenny" userId="8c9d190a88911c18" providerId="LiveId" clId="{8DE0DA05-B572-4B66-A6A4-358C9A0232A5}" dt="2025-01-21T18:23:27.646" v="138" actId="21"/>
-          <ac:spMkLst>
-            <pc:docMk/>
-            <pc:sldMk cId="81377919" sldId="362"/>
-            <ac:spMk id="3" creationId="{2821DD44-34AF-1A71-D9CE-3E41373B425C}"/>
-          </ac:spMkLst>
-        </pc:spChg>
-      </pc:sldChg>
-    </pc:docChg>
-  </pc:docChgLst>
   <pc:docChgLst>
     <pc:chgData name="Aaron McKenny" userId="fab40b6e-44fd-4d63-b855-49cdf63ca0c3" providerId="ADAL" clId="{31B5545E-8D50-4804-A017-D9CB092BA4C3}"/>
     <pc:docChg chg="undo custSel addSld delSld modSld sldOrd delMainMaster">
@@ -1063,6 +868,201 @@
       </pc:sldMasterChg>
     </pc:docChg>
   </pc:docChgLst>
+  <pc:docChgLst>
+    <pc:chgData name="Aaron McKenny" userId="8c9d190a88911c18" providerId="LiveId" clId="{8DE0DA05-B572-4B66-A6A4-358C9A0232A5}"/>
+    <pc:docChg chg="undo custSel addSld delSld modSld sldOrd">
+      <pc:chgData name="Aaron McKenny" userId="8c9d190a88911c18" providerId="LiveId" clId="{8DE0DA05-B572-4B66-A6A4-358C9A0232A5}" dt="2025-01-21T19:29:34.997" v="2219" actId="20577"/>
+      <pc:docMkLst>
+        <pc:docMk/>
+      </pc:docMkLst>
+      <pc:sldChg chg="modSp mod">
+        <pc:chgData name="Aaron McKenny" userId="8c9d190a88911c18" providerId="LiveId" clId="{8DE0DA05-B572-4B66-A6A4-358C9A0232A5}" dt="2025-01-21T19:25:28.049" v="2034" actId="948"/>
+        <pc:sldMkLst>
+          <pc:docMk/>
+          <pc:sldMk cId="1323249328" sldId="277"/>
+        </pc:sldMkLst>
+        <pc:spChg chg="mod">
+          <ac:chgData name="Aaron McKenny" userId="8c9d190a88911c18" providerId="LiveId" clId="{8DE0DA05-B572-4B66-A6A4-358C9A0232A5}" dt="2025-01-21T19:24:50.968" v="1966" actId="20577"/>
+          <ac:spMkLst>
+            <pc:docMk/>
+            <pc:sldMk cId="1323249328" sldId="277"/>
+            <ac:spMk id="2" creationId="{21DC9B4B-025C-B2D9-D736-11C2B87A803A}"/>
+          </ac:spMkLst>
+        </pc:spChg>
+        <pc:spChg chg="mod">
+          <ac:chgData name="Aaron McKenny" userId="8c9d190a88911c18" providerId="LiveId" clId="{8DE0DA05-B572-4B66-A6A4-358C9A0232A5}" dt="2025-01-21T19:25:28.049" v="2034" actId="948"/>
+          <ac:spMkLst>
+            <pc:docMk/>
+            <pc:sldMk cId="1323249328" sldId="277"/>
+            <ac:spMk id="3" creationId="{68C8CB05-75F8-5AB9-B604-7FEA7BBEF4D9}"/>
+          </ac:spMkLst>
+        </pc:spChg>
+      </pc:sldChg>
+      <pc:sldChg chg="modSp mod">
+        <pc:chgData name="Aaron McKenny" userId="8c9d190a88911c18" providerId="LiveId" clId="{8DE0DA05-B572-4B66-A6A4-358C9A0232A5}" dt="2025-01-21T18:43:11.626" v="728" actId="20577"/>
+        <pc:sldMkLst>
+          <pc:docMk/>
+          <pc:sldMk cId="3096737779" sldId="279"/>
+        </pc:sldMkLst>
+        <pc:spChg chg="mod">
+          <ac:chgData name="Aaron McKenny" userId="8c9d190a88911c18" providerId="LiveId" clId="{8DE0DA05-B572-4B66-A6A4-358C9A0232A5}" dt="2025-01-21T18:43:11.626" v="728" actId="20577"/>
+          <ac:spMkLst>
+            <pc:docMk/>
+            <pc:sldMk cId="3096737779" sldId="279"/>
+            <ac:spMk id="3" creationId="{FBE600EF-8BC0-0721-2362-EC492736C742}"/>
+          </ac:spMkLst>
+        </pc:spChg>
+      </pc:sldChg>
+      <pc:sldChg chg="modSp mod">
+        <pc:chgData name="Aaron McKenny" userId="8c9d190a88911c18" providerId="LiveId" clId="{8DE0DA05-B572-4B66-A6A4-358C9A0232A5}" dt="2025-01-21T19:02:34.740" v="1372" actId="20577"/>
+        <pc:sldMkLst>
+          <pc:docMk/>
+          <pc:sldMk cId="1849440115" sldId="280"/>
+        </pc:sldMkLst>
+        <pc:spChg chg="mod">
+          <ac:chgData name="Aaron McKenny" userId="8c9d190a88911c18" providerId="LiveId" clId="{8DE0DA05-B572-4B66-A6A4-358C9A0232A5}" dt="2025-01-21T19:02:34.740" v="1372" actId="20577"/>
+          <ac:spMkLst>
+            <pc:docMk/>
+            <pc:sldMk cId="1849440115" sldId="280"/>
+            <ac:spMk id="3" creationId="{775378BB-6208-6FD2-F870-6A2489052CA6}"/>
+          </ac:spMkLst>
+        </pc:spChg>
+      </pc:sldChg>
+      <pc:sldChg chg="modSp mod">
+        <pc:chgData name="Aaron McKenny" userId="8c9d190a88911c18" providerId="LiveId" clId="{8DE0DA05-B572-4B66-A6A4-358C9A0232A5}" dt="2025-01-21T19:12:03.950" v="1619" actId="20577"/>
+        <pc:sldMkLst>
+          <pc:docMk/>
+          <pc:sldMk cId="3188424627" sldId="281"/>
+        </pc:sldMkLst>
+      </pc:sldChg>
+      <pc:sldChg chg="modSp mod">
+        <pc:chgData name="Aaron McKenny" userId="8c9d190a88911c18" providerId="LiveId" clId="{8DE0DA05-B572-4B66-A6A4-358C9A0232A5}" dt="2025-01-21T18:25:36.731" v="197" actId="20577"/>
+        <pc:sldMkLst>
+          <pc:docMk/>
+          <pc:sldMk cId="1287068090" sldId="288"/>
+        </pc:sldMkLst>
+      </pc:sldChg>
+      <pc:sldChg chg="modSp mod">
+        <pc:chgData name="Aaron McKenny" userId="8c9d190a88911c18" providerId="LiveId" clId="{8DE0DA05-B572-4B66-A6A4-358C9A0232A5}" dt="2025-01-21T19:29:34.997" v="2219" actId="20577"/>
+        <pc:sldMkLst>
+          <pc:docMk/>
+          <pc:sldMk cId="441169049" sldId="298"/>
+        </pc:sldMkLst>
+        <pc:spChg chg="mod">
+          <ac:chgData name="Aaron McKenny" userId="8c9d190a88911c18" providerId="LiveId" clId="{8DE0DA05-B572-4B66-A6A4-358C9A0232A5}" dt="2025-01-21T19:26:10.103" v="2071" actId="20577"/>
+          <ac:spMkLst>
+            <pc:docMk/>
+            <pc:sldMk cId="441169049" sldId="298"/>
+            <ac:spMk id="2" creationId="{9402D7F2-35BB-D947-F043-0B88E04899E0}"/>
+          </ac:spMkLst>
+        </pc:spChg>
+        <pc:spChg chg="mod">
+          <ac:chgData name="Aaron McKenny" userId="8c9d190a88911c18" providerId="LiveId" clId="{8DE0DA05-B572-4B66-A6A4-358C9A0232A5}" dt="2025-01-21T19:29:34.997" v="2219" actId="20577"/>
+          <ac:spMkLst>
+            <pc:docMk/>
+            <pc:sldMk cId="441169049" sldId="298"/>
+            <ac:spMk id="3" creationId="{1BB4A81E-9C5A-B504-8D81-CB4C8EA621BF}"/>
+          </ac:spMkLst>
+        </pc:spChg>
+      </pc:sldChg>
+      <pc:sldChg chg="modSp mod">
+        <pc:chgData name="Aaron McKenny" userId="8c9d190a88911c18" providerId="LiveId" clId="{8DE0DA05-B572-4B66-A6A4-358C9A0232A5}" dt="2025-01-21T18:24:48.304" v="193" actId="20577"/>
+        <pc:sldMkLst>
+          <pc:docMk/>
+          <pc:sldMk cId="347184342" sldId="300"/>
+        </pc:sldMkLst>
+        <pc:spChg chg="mod">
+          <ac:chgData name="Aaron McKenny" userId="8c9d190a88911c18" providerId="LiveId" clId="{8DE0DA05-B572-4B66-A6A4-358C9A0232A5}" dt="2025-01-21T18:24:48.304" v="193" actId="20577"/>
+          <ac:spMkLst>
+            <pc:docMk/>
+            <pc:sldMk cId="347184342" sldId="300"/>
+            <ac:spMk id="3" creationId="{0F1E47E1-FCED-AEBE-977C-5A0B03585940}"/>
+          </ac:spMkLst>
+        </pc:spChg>
+        <pc:picChg chg="mod">
+          <ac:chgData name="Aaron McKenny" userId="8c9d190a88911c18" providerId="LiveId" clId="{8DE0DA05-B572-4B66-A6A4-358C9A0232A5}" dt="2025-01-21T18:24:29.532" v="182" actId="14100"/>
+          <ac:picMkLst>
+            <pc:docMk/>
+            <pc:sldMk cId="347184342" sldId="300"/>
+            <ac:picMk id="5" creationId="{FEA625B2-5095-C498-1BF1-9511546A2084}"/>
+          </ac:picMkLst>
+        </pc:picChg>
+      </pc:sldChg>
+      <pc:sldChg chg="ord">
+        <pc:chgData name="Aaron McKenny" userId="8c9d190a88911c18" providerId="LiveId" clId="{8DE0DA05-B572-4B66-A6A4-358C9A0232A5}" dt="2025-01-21T16:54:36.042" v="42"/>
+        <pc:sldMkLst>
+          <pc:docMk/>
+          <pc:sldMk cId="3113912552" sldId="351"/>
+        </pc:sldMkLst>
+      </pc:sldChg>
+      <pc:sldChg chg="modSp del mod">
+        <pc:chgData name="Aaron McKenny" userId="8c9d190a88911c18" providerId="LiveId" clId="{8DE0DA05-B572-4B66-A6A4-358C9A0232A5}" dt="2025-01-21T18:24:55.681" v="194" actId="47"/>
+        <pc:sldMkLst>
+          <pc:docMk/>
+          <pc:sldMk cId="3956547567" sldId="356"/>
+        </pc:sldMkLst>
+      </pc:sldChg>
+      <pc:sldChg chg="modSp mod">
+        <pc:chgData name="Aaron McKenny" userId="8c9d190a88911c18" providerId="LiveId" clId="{8DE0DA05-B572-4B66-A6A4-358C9A0232A5}" dt="2025-01-21T18:49:21.839" v="1099" actId="20577"/>
+        <pc:sldMkLst>
+          <pc:docMk/>
+          <pc:sldMk cId="4212261276" sldId="357"/>
+        </pc:sldMkLst>
+        <pc:spChg chg="mod">
+          <ac:chgData name="Aaron McKenny" userId="8c9d190a88911c18" providerId="LiveId" clId="{8DE0DA05-B572-4B66-A6A4-358C9A0232A5}" dt="2025-01-21T18:49:21.839" v="1099" actId="20577"/>
+          <ac:spMkLst>
+            <pc:docMk/>
+            <pc:sldMk cId="4212261276" sldId="357"/>
+            <ac:spMk id="3" creationId="{32EEEBCE-0ADB-8187-2DCD-4E0168AA282D}"/>
+          </ac:spMkLst>
+        </pc:spChg>
+      </pc:sldChg>
+      <pc:sldChg chg="modSp mod">
+        <pc:chgData name="Aaron McKenny" userId="8c9d190a88911c18" providerId="LiveId" clId="{8DE0DA05-B572-4B66-A6A4-358C9A0232A5}" dt="2025-01-21T19:23:49.165" v="1943" actId="20577"/>
+        <pc:sldMkLst>
+          <pc:docMk/>
+          <pc:sldMk cId="3661507078" sldId="358"/>
+        </pc:sldMkLst>
+      </pc:sldChg>
+      <pc:sldChg chg="modSp new del mod">
+        <pc:chgData name="Aaron McKenny" userId="8c9d190a88911c18" providerId="LiveId" clId="{8DE0DA05-B572-4B66-A6A4-358C9A0232A5}" dt="2025-01-21T16:51:32.898" v="7" actId="47"/>
+        <pc:sldMkLst>
+          <pc:docMk/>
+          <pc:sldMk cId="3281436423" sldId="360"/>
+        </pc:sldMkLst>
+      </pc:sldChg>
+      <pc:sldChg chg="addSp modSp add mod">
+        <pc:chgData name="Aaron McKenny" userId="8c9d190a88911c18" providerId="LiveId" clId="{8DE0DA05-B572-4B66-A6A4-358C9A0232A5}" dt="2025-01-21T18:26:08.444" v="201" actId="5793"/>
+        <pc:sldMkLst>
+          <pc:docMk/>
+          <pc:sldMk cId="686485639" sldId="361"/>
+        </pc:sldMkLst>
+      </pc:sldChg>
+      <pc:sldChg chg="modSp new mod">
+        <pc:chgData name="Aaron McKenny" userId="8c9d190a88911c18" providerId="LiveId" clId="{8DE0DA05-B572-4B66-A6A4-358C9A0232A5}" dt="2025-01-21T18:23:27.646" v="138" actId="21"/>
+        <pc:sldMkLst>
+          <pc:docMk/>
+          <pc:sldMk cId="81377919" sldId="362"/>
+        </pc:sldMkLst>
+        <pc:spChg chg="mod">
+          <ac:chgData name="Aaron McKenny" userId="8c9d190a88911c18" providerId="LiveId" clId="{8DE0DA05-B572-4B66-A6A4-358C9A0232A5}" dt="2025-01-21T16:57:37.448" v="68" actId="20577"/>
+          <ac:spMkLst>
+            <pc:docMk/>
+            <pc:sldMk cId="81377919" sldId="362"/>
+            <ac:spMk id="2" creationId="{EDF66317-9779-FA0A-8853-6A2401F4F16E}"/>
+          </ac:spMkLst>
+        </pc:spChg>
+        <pc:spChg chg="mod">
+          <ac:chgData name="Aaron McKenny" userId="8c9d190a88911c18" providerId="LiveId" clId="{8DE0DA05-B572-4B66-A6A4-358C9A0232A5}" dt="2025-01-21T18:23:27.646" v="138" actId="21"/>
+          <ac:spMkLst>
+            <pc:docMk/>
+            <pc:sldMk cId="81377919" sldId="362"/>
+            <ac:spMk id="3" creationId="{2821DD44-34AF-1A71-D9CE-3E41373B425C}"/>
+          </ac:spMkLst>
+        </pc:spChg>
+      </pc:sldChg>
+    </pc:docChg>
+  </pc:docChgLst>
 </pc:chgInfo>
 </file>
 
@@ -4870,7 +4870,7 @@
           <a:p>
             <a:fld id="{740993C0-9AB3-4209-9AF9-896CEF8BC588}" type="datetimeFigureOut">
               <a:rPr lang="en-US" smtClean="0"/>
-              <a:t>1/29/2025</a:t>
+              <a:t>10/14/2026</a:t>
             </a:fld>
             <a:endParaRPr lang="en-US"/>
           </a:p>
@@ -5040,7 +5040,7 @@
           <a:p>
             <a:fld id="{740993C0-9AB3-4209-9AF9-896CEF8BC588}" type="datetimeFigureOut">
               <a:rPr lang="en-US" smtClean="0"/>
-              <a:t>1/29/2025</a:t>
+              <a:t>10/14/2026</a:t>
             </a:fld>
             <a:endParaRPr lang="en-US"/>
           </a:p>
@@ -5286,7 +5286,7 @@
           <a:p>
             <a:fld id="{740993C0-9AB3-4209-9AF9-896CEF8BC588}" type="datetimeFigureOut">
               <a:rPr lang="en-US" smtClean="0"/>
-              <a:t>1/29/2025</a:t>
+              <a:t>10/14/2026</a:t>
             </a:fld>
             <a:endParaRPr lang="en-US"/>
           </a:p>
@@ -5518,7 +5518,7 @@
           <a:p>
             <a:fld id="{740993C0-9AB3-4209-9AF9-896CEF8BC588}" type="datetimeFigureOut">
               <a:rPr lang="en-US" smtClean="0"/>
-              <a:t>1/29/2025</a:t>
+              <a:t>10/14/2026</a:t>
             </a:fld>
             <a:endParaRPr lang="en-US"/>
           </a:p>
@@ -5885,7 +5885,7 @@
           <a:p>
             <a:fld id="{740993C0-9AB3-4209-9AF9-896CEF8BC588}" type="datetimeFigureOut">
               <a:rPr lang="en-US" smtClean="0"/>
-              <a:t>1/29/2025</a:t>
+              <a:t>10/14/2026</a:t>
             </a:fld>
             <a:endParaRPr lang="en-US"/>
           </a:p>
@@ -6003,7 +6003,7 @@
           <a:p>
             <a:fld id="{740993C0-9AB3-4209-9AF9-896CEF8BC588}" type="datetimeFigureOut">
               <a:rPr lang="en-US" smtClean="0"/>
-              <a:t>1/29/2025</a:t>
+              <a:t>10/14/2026</a:t>
             </a:fld>
             <a:endParaRPr lang="en-US"/>
           </a:p>
@@ -6098,7 +6098,7 @@
           <a:p>
             <a:fld id="{740993C0-9AB3-4209-9AF9-896CEF8BC588}" type="datetimeFigureOut">
               <a:rPr lang="en-US" smtClean="0"/>
-              <a:t>1/29/2025</a:t>
+              <a:t>10/14/2026</a:t>
             </a:fld>
             <a:endParaRPr lang="en-US"/>
           </a:p>
@@ -6651,7 +6651,7 @@
           <a:p>
             <a:fld id="{740993C0-9AB3-4209-9AF9-896CEF8BC588}" type="datetimeFigureOut">
               <a:rPr lang="en-US" smtClean="0"/>
-              <a:t>1/29/2025</a:t>
+              <a:t>10/14/2026</a:t>
             </a:fld>
             <a:endParaRPr lang="en-US"/>
           </a:p>
@@ -6908,7 +6908,7 @@
           <a:p>
             <a:fld id="{740993C0-9AB3-4209-9AF9-896CEF8BC588}" type="datetimeFigureOut">
               <a:rPr lang="en-US" smtClean="0"/>
-              <a:t>1/29/2025</a:t>
+              <a:t>10/14/2026</a:t>
             </a:fld>
             <a:endParaRPr lang="en-US"/>
           </a:p>
@@ -7078,7 +7078,7 @@
           <a:p>
             <a:fld id="{740993C0-9AB3-4209-9AF9-896CEF8BC588}" type="datetimeFigureOut">
               <a:rPr lang="en-US" smtClean="0"/>
-              <a:t>1/29/2025</a:t>
+              <a:t>10/14/2026</a:t>
             </a:fld>
             <a:endParaRPr lang="en-US"/>
           </a:p>
@@ -7258,7 +7258,7 @@
           <a:p>
             <a:fld id="{740993C0-9AB3-4209-9AF9-896CEF8BC588}" type="datetimeFigureOut">
               <a:rPr lang="en-US" smtClean="0"/>
-              <a:t>1/29/2025</a:t>
+              <a:t>10/14/2026</a:t>
             </a:fld>
             <a:endParaRPr lang="en-US"/>
           </a:p>
@@ -10154,7 +10154,7 @@
           <a:p>
             <a:fld id="{740993C0-9AB3-4209-9AF9-896CEF8BC588}" type="datetimeFigureOut">
               <a:rPr lang="en-US" smtClean="0"/>
-              <a:t>1/29/2025</a:t>
+              <a:t>10/14/2026</a:t>
             </a:fld>
             <a:endParaRPr lang="en-US"/>
           </a:p>
@@ -17405,7 +17405,7 @@
               <a:rPr lang="en-US" dirty="0">
                 <a:sym typeface="Wingdings" panose="05000000000000000000" pitchFamily="2" charset="2"/>
               </a:rPr>
-              <a:t>: Happy, happier, happiest, happily, happiness</a:t>
+              <a:t>: Happy, happier, happiest, happily</a:t>
             </a:r>
           </a:p>
           <a:p>
@@ -17553,7 +17553,7 @@
                 </a:solidFill>
                 <a:sym typeface="Wingdings" panose="05000000000000000000" pitchFamily="2" charset="2"/>
               </a:rPr>
-              <a:t>Happiness</a:t>
+              <a:t>Happier</a:t>
             </a:r>
             <a:r>
               <a:rPr lang="en-US" dirty="0" err="1">
@@ -17569,6 +17569,36 @@
                 <a:sym typeface="Wingdings" panose="05000000000000000000" pitchFamily="2" charset="2"/>
               </a:rPr>
               <a:t>Happy</a:t>
+            </a:r>
+            <a:r>
+              <a:rPr lang="en-US" dirty="0">
+                <a:sym typeface="Wingdings" panose="05000000000000000000" pitchFamily="2" charset="2"/>
+              </a:rPr>
+              <a:t>, </a:t>
+            </a:r>
+            <a:r>
+              <a:rPr lang="en-US" dirty="0" err="1">
+                <a:solidFill>
+                  <a:srgbClr val="4F81BD"/>
+                </a:solidFill>
+                <a:sym typeface="Wingdings" panose="05000000000000000000" pitchFamily="2" charset="2"/>
+              </a:rPr>
+              <a:t>Days</a:t>
+            </a:r>
+            <a:r>
+              <a:rPr lang="en-US" dirty="0" err="1">
+                <a:sym typeface="Wingdings" panose="05000000000000000000" pitchFamily="2" charset="2"/>
+              </a:rPr>
+              <a:t></a:t>
+            </a:r>
+            <a:r>
+              <a:rPr lang="en-US" dirty="0" err="1">
+                <a:solidFill>
+                  <a:srgbClr val="4F81BD"/>
+                </a:solidFill>
+                <a:sym typeface="Wingdings" panose="05000000000000000000" pitchFamily="2" charset="2"/>
+              </a:rPr>
+              <a:t>Day</a:t>
             </a:r>
             <a:r>
               <a:rPr lang="en-US" dirty="0">

</xml_diff>